<commit_message>
Tạo bộ 8 Slide bài giảng định hướng môn Tin học (Tiết 0) Lớp 1-8 chuẩn mẫu UNIGO
</commit_message>
<xml_diff>
--- a/Hệ thống mẫu văn bản/Mẫu slide UNIGO.pptx
+++ b/Hệ thống mẫu văn bản/Mẫu slide UNIGO.pptx
@@ -7,7 +7,8 @@
   <p:sldIdLst>
     <p:sldId id="256" r:id="rId2"/>
     <p:sldId id="258" r:id="rId3"/>
-    <p:sldId id="257" r:id="rId4"/>
+    <p:sldId id="259" r:id="rId4"/>
+    <p:sldId id="257" r:id="rId5"/>
   </p:sldIdLst>
   <p:sldSz cx="12192000" cy="6858000"/>
   <p:notesSz cx="6858000" cy="9144000"/>
@@ -3527,12 +3528,14 @@
         </p:nvSpPr>
         <p:spPr>
           <a:xfrm>
-            <a:off x="2269958" y="540384"/>
+            <a:off x="3930315" y="215531"/>
             <a:ext cx="3826042" cy="861546"/>
           </a:xfrm>
         </p:spPr>
         <p:txBody>
-          <a:bodyPr/>
+          <a:bodyPr>
+            <a:normAutofit/>
+          </a:bodyPr>
           <a:lstStyle/>
           <a:p>
             <a:r>
@@ -3579,14 +3582,17 @@
               </a:rPr>
               <a:t>lớp</a:t>
             </a:r>
-            <a:endParaRPr lang="en-US" dirty="0">
-              <a:solidFill>
-                <a:schemeClr val="tx2">
-                  <a:lumMod val="75000"/>
-                  <a:lumOff val="25000"/>
-                </a:schemeClr>
-              </a:solidFill>
-            </a:endParaRPr>
+            <a:r>
+              <a:rPr lang="en-US" dirty="0">
+                <a:solidFill>
+                  <a:schemeClr val="tx2">
+                    <a:lumMod val="75000"/>
+                    <a:lumOff val="25000"/>
+                  </a:schemeClr>
+                </a:solidFill>
+              </a:rPr>
+              <a:t> </a:t>
+            </a:r>
           </a:p>
         </p:txBody>
       </p:sp>
@@ -3604,6 +3610,128 @@
 </file>
 
 <file path=ppt/slides/slide3.xml><?xml version="1.0" encoding="utf-8"?>
+<p:sld xmlns:a="http://schemas.openxmlformats.org/drawingml/2006/main" xmlns:r="http://schemas.openxmlformats.org/officeDocument/2006/relationships" xmlns:p="http://schemas.openxmlformats.org/presentationml/2006/main">
+  <p:cSld>
+    <p:spTree>
+      <p:nvGrpSpPr>
+        <p:cNvPr id="1" name="">
+          <a:extLst>
+            <a:ext uri="{FF2B5EF4-FFF2-40B4-BE49-F238E27FC236}">
+              <a16:creationId xmlns:a16="http://schemas.microsoft.com/office/drawing/2014/main" id="{D3F3F47A-2A03-62D2-8A5D-F03932A437A1}"/>
+            </a:ext>
+          </a:extLst>
+        </p:cNvPr>
+        <p:cNvGrpSpPr/>
+        <p:nvPr/>
+      </p:nvGrpSpPr>
+      <p:grpSpPr>
+        <a:xfrm>
+          <a:off x="0" y="0"/>
+          <a:ext cx="0" cy="0"/>
+          <a:chOff x="0" y="0"/>
+          <a:chExt cx="0" cy="0"/>
+        </a:xfrm>
+      </p:grpSpPr>
+      <p:sp>
+        <p:nvSpPr>
+          <p:cNvPr id="2" name="Title 1">
+            <a:extLst>
+              <a:ext uri="{FF2B5EF4-FFF2-40B4-BE49-F238E27FC236}">
+                <a16:creationId xmlns:a16="http://schemas.microsoft.com/office/drawing/2014/main" id="{32DE052A-67C4-3C30-0BE8-A144FDC576E8}"/>
+              </a:ext>
+            </a:extLst>
+          </p:cNvPr>
+          <p:cNvSpPr>
+            <a:spLocks noGrp="1"/>
+          </p:cNvSpPr>
+          <p:nvPr>
+            <p:ph type="title"/>
+          </p:nvPr>
+        </p:nvSpPr>
+        <p:spPr>
+          <a:xfrm>
+            <a:off x="3605463" y="335847"/>
+            <a:ext cx="3826042" cy="861546"/>
+          </a:xfrm>
+        </p:spPr>
+        <p:txBody>
+          <a:bodyPr>
+            <a:normAutofit/>
+          </a:bodyPr>
+          <a:lstStyle/>
+          <a:p>
+            <a:r>
+              <a:rPr lang="en-US" dirty="0">
+                <a:solidFill>
+                  <a:schemeClr val="tx2">
+                    <a:lumMod val="75000"/>
+                    <a:lumOff val="25000"/>
+                  </a:schemeClr>
+                </a:solidFill>
+              </a:rPr>
+              <a:t>Môn Tin </a:t>
+            </a:r>
+            <a:r>
+              <a:rPr lang="en-US" dirty="0" err="1">
+                <a:solidFill>
+                  <a:schemeClr val="tx2">
+                    <a:lumMod val="75000"/>
+                    <a:lumOff val="25000"/>
+                  </a:schemeClr>
+                </a:solidFill>
+              </a:rPr>
+              <a:t>học</a:t>
+            </a:r>
+            <a:r>
+              <a:rPr lang="en-US" dirty="0">
+                <a:solidFill>
+                  <a:schemeClr val="tx2">
+                    <a:lumMod val="75000"/>
+                    <a:lumOff val="25000"/>
+                  </a:schemeClr>
+                </a:solidFill>
+              </a:rPr>
+              <a:t> </a:t>
+            </a:r>
+            <a:r>
+              <a:rPr lang="en-US" dirty="0" err="1">
+                <a:solidFill>
+                  <a:schemeClr val="tx2">
+                    <a:lumMod val="75000"/>
+                    <a:lumOff val="25000"/>
+                  </a:schemeClr>
+                </a:solidFill>
+              </a:rPr>
+              <a:t>lớp</a:t>
+            </a:r>
+            <a:r>
+              <a:rPr lang="en-US" dirty="0">
+                <a:solidFill>
+                  <a:schemeClr val="tx2">
+                    <a:lumMod val="75000"/>
+                    <a:lumOff val="25000"/>
+                  </a:schemeClr>
+                </a:solidFill>
+              </a:rPr>
+              <a:t> </a:t>
+            </a:r>
+          </a:p>
+        </p:txBody>
+      </p:sp>
+    </p:spTree>
+    <p:extLst>
+      <p:ext uri="{BB962C8B-B14F-4D97-AF65-F5344CB8AC3E}">
+        <p14:creationId xmlns:p14="http://schemas.microsoft.com/office/powerpoint/2010/main" val="504304636"/>
+      </p:ext>
+    </p:extLst>
+  </p:cSld>
+  <p:clrMapOvr>
+    <a:masterClrMapping/>
+  </p:clrMapOvr>
+</p:sld>
+</file>
+
+<file path=ppt/slides/slide4.xml><?xml version="1.0" encoding="utf-8"?>
 <p:sld xmlns:a="http://schemas.openxmlformats.org/drawingml/2006/main" xmlns:r="http://schemas.openxmlformats.org/officeDocument/2006/relationships" xmlns:p="http://schemas.openxmlformats.org/presentationml/2006/main">
   <p:cSld>
     <p:spTree>

</xml_diff>